<commit_message>
Text updates: hero subtitle, cycling words, card copy, remove Where we're headed section
Co-Authored-By: Claude Sonnet 4.6 <noreply@anthropic.com>
</commit_message>
<xml_diff>
--- a/Acernis/public/Logos Website Kunden.pptx
+++ b/Acernis/public/Logos Website Kunden.pptx
@@ -7,6 +7,7 @@
   <p:sldIdLst>
     <p:sldId id="256" r:id="rId2"/>
     <p:sldId id="257" r:id="rId3"/>
+    <p:sldId id="258" r:id="rId4"/>
   </p:sldIdLst>
   <p:sldSz cx="12192000" cy="6858000"/>
   <p:notesSz cx="6858000" cy="9144000"/>
@@ -271,7 +272,7 @@
           <a:p>
             <a:fld id="{D06D05ED-7711-4491-87BD-8956D76A6999}" type="datetimeFigureOut">
               <a:rPr lang="en-US" smtClean="0"/>
-              <a:t>6/9/2026</a:t>
+              <a:t>6/10/2026</a:t>
             </a:fld>
             <a:endParaRPr lang="en-US"/>
           </a:p>
@@ -469,7 +470,7 @@
           <a:p>
             <a:fld id="{D06D05ED-7711-4491-87BD-8956D76A6999}" type="datetimeFigureOut">
               <a:rPr lang="en-US" smtClean="0"/>
-              <a:t>6/9/2026</a:t>
+              <a:t>6/10/2026</a:t>
             </a:fld>
             <a:endParaRPr lang="en-US"/>
           </a:p>
@@ -677,7 +678,7 @@
           <a:p>
             <a:fld id="{D06D05ED-7711-4491-87BD-8956D76A6999}" type="datetimeFigureOut">
               <a:rPr lang="en-US" smtClean="0"/>
-              <a:t>6/9/2026</a:t>
+              <a:t>6/10/2026</a:t>
             </a:fld>
             <a:endParaRPr lang="en-US"/>
           </a:p>
@@ -875,7 +876,7 @@
           <a:p>
             <a:fld id="{D06D05ED-7711-4491-87BD-8956D76A6999}" type="datetimeFigureOut">
               <a:rPr lang="en-US" smtClean="0"/>
-              <a:t>6/9/2026</a:t>
+              <a:t>6/10/2026</a:t>
             </a:fld>
             <a:endParaRPr lang="en-US"/>
           </a:p>
@@ -1150,7 +1151,7 @@
           <a:p>
             <a:fld id="{D06D05ED-7711-4491-87BD-8956D76A6999}" type="datetimeFigureOut">
               <a:rPr lang="en-US" smtClean="0"/>
-              <a:t>6/9/2026</a:t>
+              <a:t>6/10/2026</a:t>
             </a:fld>
             <a:endParaRPr lang="en-US"/>
           </a:p>
@@ -1415,7 +1416,7 @@
           <a:p>
             <a:fld id="{D06D05ED-7711-4491-87BD-8956D76A6999}" type="datetimeFigureOut">
               <a:rPr lang="en-US" smtClean="0"/>
-              <a:t>6/9/2026</a:t>
+              <a:t>6/10/2026</a:t>
             </a:fld>
             <a:endParaRPr lang="en-US"/>
           </a:p>
@@ -1827,7 +1828,7 @@
           <a:p>
             <a:fld id="{D06D05ED-7711-4491-87BD-8956D76A6999}" type="datetimeFigureOut">
               <a:rPr lang="en-US" smtClean="0"/>
-              <a:t>6/9/2026</a:t>
+              <a:t>6/10/2026</a:t>
             </a:fld>
             <a:endParaRPr lang="en-US"/>
           </a:p>
@@ -1968,7 +1969,7 @@
           <a:p>
             <a:fld id="{D06D05ED-7711-4491-87BD-8956D76A6999}" type="datetimeFigureOut">
               <a:rPr lang="en-US" smtClean="0"/>
-              <a:t>6/9/2026</a:t>
+              <a:t>6/10/2026</a:t>
             </a:fld>
             <a:endParaRPr lang="en-US"/>
           </a:p>
@@ -2081,7 +2082,7 @@
           <a:p>
             <a:fld id="{D06D05ED-7711-4491-87BD-8956D76A6999}" type="datetimeFigureOut">
               <a:rPr lang="en-US" smtClean="0"/>
-              <a:t>6/9/2026</a:t>
+              <a:t>6/10/2026</a:t>
             </a:fld>
             <a:endParaRPr lang="en-US"/>
           </a:p>
@@ -2392,7 +2393,7 @@
           <a:p>
             <a:fld id="{D06D05ED-7711-4491-87BD-8956D76A6999}" type="datetimeFigureOut">
               <a:rPr lang="en-US" smtClean="0"/>
-              <a:t>6/9/2026</a:t>
+              <a:t>6/10/2026</a:t>
             </a:fld>
             <a:endParaRPr lang="en-US"/>
           </a:p>
@@ -2680,7 +2681,7 @@
           <a:p>
             <a:fld id="{D06D05ED-7711-4491-87BD-8956D76A6999}" type="datetimeFigureOut">
               <a:rPr lang="en-US" smtClean="0"/>
-              <a:t>6/9/2026</a:t>
+              <a:t>6/10/2026</a:t>
             </a:fld>
             <a:endParaRPr lang="en-US"/>
           </a:p>
@@ -2921,7 +2922,7 @@
           <a:p>
             <a:fld id="{D06D05ED-7711-4491-87BD-8956D76A6999}" type="datetimeFigureOut">
               <a:rPr lang="en-US" smtClean="0"/>
-              <a:t>6/9/2026</a:t>
+              <a:t>6/10/2026</a:t>
             </a:fld>
             <a:endParaRPr lang="en-US"/>
           </a:p>
@@ -4177,6 +4178,492 @@
 </p:sld>
 </file>
 
+<file path=ppt/slides/slide3.xml><?xml version="1.0" encoding="utf-8"?>
+<p:sld xmlns:a="http://schemas.openxmlformats.org/drawingml/2006/main" xmlns:r="http://schemas.openxmlformats.org/officeDocument/2006/relationships" xmlns:p="http://schemas.openxmlformats.org/presentationml/2006/main">
+  <p:cSld>
+    <p:spTree>
+      <p:nvGrpSpPr>
+        <p:cNvPr id="1" name="">
+          <a:extLst>
+            <a:ext uri="{FF2B5EF4-FFF2-40B4-BE49-F238E27FC236}">
+              <a16:creationId xmlns:a16="http://schemas.microsoft.com/office/drawing/2014/main" id="{EC8ABA58-85CF-A653-D9FA-5890761E915F}"/>
+            </a:ext>
+          </a:extLst>
+        </p:cNvPr>
+        <p:cNvGrpSpPr/>
+        <p:nvPr/>
+      </p:nvGrpSpPr>
+      <p:grpSpPr>
+        <a:xfrm>
+          <a:off x="0" y="0"/>
+          <a:ext cx="0" cy="0"/>
+          <a:chOff x="0" y="0"/>
+          <a:chExt cx="0" cy="0"/>
+        </a:xfrm>
+      </p:grpSpPr>
+      <p:pic>
+        <p:nvPicPr>
+          <p:cNvPr id="5" name="Graphic 4">
+            <a:extLst>
+              <a:ext uri="{FF2B5EF4-FFF2-40B4-BE49-F238E27FC236}">
+                <a16:creationId xmlns:a16="http://schemas.microsoft.com/office/drawing/2014/main" id="{39156CB8-55D1-42A5-73A6-93871292917F}"/>
+              </a:ext>
+            </a:extLst>
+          </p:cNvPr>
+          <p:cNvPicPr>
+            <a:picLocks noChangeAspect="1"/>
+          </p:cNvPicPr>
+          <p:nvPr/>
+        </p:nvPicPr>
+        <p:blipFill>
+          <a:blip>
+            <a:duotone>
+              <a:schemeClr val="bg2">
+                <a:shade val="45000"/>
+                <a:satMod val="135000"/>
+              </a:schemeClr>
+              <a:prstClr val="white"/>
+            </a:duotone>
+            <a:lum bright="-2000"/>
+            <a:extLst>
+              <a:ext uri="{96DAC541-7B7A-43D3-8B79-37D633B846F1}">
+                <asvg:svgBlip xmlns:asvg="http://schemas.microsoft.com/office/drawing/2016/SVG/main" r:embed="rId2"/>
+              </a:ext>
+            </a:extLst>
+          </a:blip>
+          <a:stretch>
+            <a:fillRect/>
+          </a:stretch>
+        </p:blipFill>
+        <p:spPr>
+          <a:xfrm>
+            <a:off x="1596571" y="4238423"/>
+            <a:ext cx="4300547" cy="1919287"/>
+          </a:xfrm>
+          <a:prstGeom prst="rect">
+            <a:avLst/>
+          </a:prstGeom>
+        </p:spPr>
+      </p:pic>
+      <p:pic>
+        <p:nvPicPr>
+          <p:cNvPr id="7" name="Picture 6">
+            <a:extLst>
+              <a:ext uri="{FF2B5EF4-FFF2-40B4-BE49-F238E27FC236}">
+                <a16:creationId xmlns:a16="http://schemas.microsoft.com/office/drawing/2014/main" id="{ED97800D-2E9D-79EE-6F5D-5258726772A0}"/>
+              </a:ext>
+            </a:extLst>
+          </p:cNvPr>
+          <p:cNvPicPr>
+            <a:picLocks noChangeAspect="1"/>
+          </p:cNvPicPr>
+          <p:nvPr/>
+        </p:nvPicPr>
+        <p:blipFill>
+          <a:blip r:embed="rId3">
+            <a:duotone>
+              <a:schemeClr val="bg2">
+                <a:shade val="45000"/>
+                <a:satMod val="135000"/>
+              </a:schemeClr>
+              <a:prstClr val="white"/>
+            </a:duotone>
+            <a:extLst>
+              <a:ext uri="{BEBA8EAE-BF5A-486C-A8C5-ECC9F3942E4B}">
+                <a14:imgProps xmlns:a14="http://schemas.microsoft.com/office/drawing/2010/main">
+                  <a14:imgLayer r:embed="rId4">
+                    <a14:imgEffect>
+                      <a14:sharpenSoften amount="100000"/>
+                    </a14:imgEffect>
+                    <a14:imgEffect>
+                      <a14:brightnessContrast bright="-100000" contrast="100000"/>
+                    </a14:imgEffect>
+                  </a14:imgLayer>
+                </a14:imgProps>
+              </a:ext>
+              <a:ext uri="{28A0092B-C50C-407E-A947-70E740481C1C}">
+                <a14:useLocalDpi xmlns:a14="http://schemas.microsoft.com/office/drawing/2010/main" val="0"/>
+              </a:ext>
+            </a:extLst>
+          </a:blip>
+          <a:stretch>
+            <a:fillRect/>
+          </a:stretch>
+        </p:blipFill>
+        <p:spPr>
+          <a:xfrm>
+            <a:off x="9081469" y="2458699"/>
+            <a:ext cx="2857500" cy="1619250"/>
+          </a:xfrm>
+          <a:prstGeom prst="rect">
+            <a:avLst/>
+          </a:prstGeom>
+          <a:ln w="34298" cap="flat">
+            <a:noFill/>
+            <a:prstDash val="solid"/>
+            <a:miter/>
+          </a:ln>
+        </p:spPr>
+      </p:pic>
+      <p:pic>
+        <p:nvPicPr>
+          <p:cNvPr id="11" name="Picture 10">
+            <a:extLst>
+              <a:ext uri="{FF2B5EF4-FFF2-40B4-BE49-F238E27FC236}">
+                <a16:creationId xmlns:a16="http://schemas.microsoft.com/office/drawing/2014/main" id="{F2E3709B-A52A-E520-4AA1-C25741C4D57D}"/>
+              </a:ext>
+            </a:extLst>
+          </p:cNvPr>
+          <p:cNvPicPr>
+            <a:picLocks noChangeAspect="1"/>
+          </p:cNvPicPr>
+          <p:nvPr/>
+        </p:nvPicPr>
+        <p:blipFill>
+          <a:blip r:embed="rId5">
+            <a:duotone>
+              <a:schemeClr val="bg2">
+                <a:shade val="45000"/>
+                <a:satMod val="135000"/>
+              </a:schemeClr>
+              <a:prstClr val="white"/>
+            </a:duotone>
+            <a:extLst>
+              <a:ext uri="{BEBA8EAE-BF5A-486C-A8C5-ECC9F3942E4B}">
+                <a14:imgProps xmlns:a14="http://schemas.microsoft.com/office/drawing/2010/main">
+                  <a14:imgLayer r:embed="rId6">
+                    <a14:imgEffect>
+                      <a14:sharpenSoften amount="100000"/>
+                    </a14:imgEffect>
+                    <a14:imgEffect>
+                      <a14:brightnessContrast bright="-100000" contrast="100000"/>
+                    </a14:imgEffect>
+                  </a14:imgLayer>
+                </a14:imgProps>
+              </a:ext>
+              <a:ext uri="{28A0092B-C50C-407E-A947-70E740481C1C}">
+                <a14:useLocalDpi xmlns:a14="http://schemas.microsoft.com/office/drawing/2010/main" val="0"/>
+              </a:ext>
+            </a:extLst>
+          </a:blip>
+          <a:stretch>
+            <a:fillRect/>
+          </a:stretch>
+        </p:blipFill>
+        <p:spPr>
+          <a:xfrm>
+            <a:off x="7433540" y="4604316"/>
+            <a:ext cx="4193830" cy="1051085"/>
+          </a:xfrm>
+          <a:prstGeom prst="rect">
+            <a:avLst/>
+          </a:prstGeom>
+          <a:ln w="34298" cap="flat">
+            <a:noFill/>
+            <a:prstDash val="solid"/>
+            <a:miter/>
+          </a:ln>
+        </p:spPr>
+      </p:pic>
+      <p:pic>
+        <p:nvPicPr>
+          <p:cNvPr id="13" name="Picture 12">
+            <a:extLst>
+              <a:ext uri="{FF2B5EF4-FFF2-40B4-BE49-F238E27FC236}">
+                <a16:creationId xmlns:a16="http://schemas.microsoft.com/office/drawing/2014/main" id="{07D09C3A-B1F5-7C77-AE9D-9B6ECB6BB519}"/>
+              </a:ext>
+            </a:extLst>
+          </p:cNvPr>
+          <p:cNvPicPr>
+            <a:picLocks noChangeAspect="1"/>
+          </p:cNvPicPr>
+          <p:nvPr/>
+        </p:nvPicPr>
+        <p:blipFill>
+          <a:blip r:embed="rId7">
+            <a:duotone>
+              <a:schemeClr val="bg2">
+                <a:shade val="45000"/>
+                <a:satMod val="135000"/>
+              </a:schemeClr>
+              <a:prstClr val="white"/>
+            </a:duotone>
+            <a:extLst>
+              <a:ext uri="{BEBA8EAE-BF5A-486C-A8C5-ECC9F3942E4B}">
+                <a14:imgProps xmlns:a14="http://schemas.microsoft.com/office/drawing/2010/main">
+                  <a14:imgLayer r:embed="rId8">
+                    <a14:imgEffect>
+                      <a14:sharpenSoften amount="100000"/>
+                    </a14:imgEffect>
+                    <a14:imgEffect>
+                      <a14:brightnessContrast bright="-100000" contrast="100000"/>
+                    </a14:imgEffect>
+                  </a14:imgLayer>
+                </a14:imgProps>
+              </a:ext>
+              <a:ext uri="{28A0092B-C50C-407E-A947-70E740481C1C}">
+                <a14:useLocalDpi xmlns:a14="http://schemas.microsoft.com/office/drawing/2010/main" val="0"/>
+              </a:ext>
+            </a:extLst>
+          </a:blip>
+          <a:stretch>
+            <a:fillRect/>
+          </a:stretch>
+        </p:blipFill>
+        <p:spPr>
+          <a:xfrm>
+            <a:off x="341104" y="2532803"/>
+            <a:ext cx="7367431" cy="1018778"/>
+          </a:xfrm>
+          <a:prstGeom prst="rect">
+            <a:avLst/>
+          </a:prstGeom>
+        </p:spPr>
+      </p:pic>
+      <p:pic>
+        <p:nvPicPr>
+          <p:cNvPr id="15" name="Picture 14">
+            <a:extLst>
+              <a:ext uri="{FF2B5EF4-FFF2-40B4-BE49-F238E27FC236}">
+                <a16:creationId xmlns:a16="http://schemas.microsoft.com/office/drawing/2014/main" id="{307E633E-DAC7-9381-36CD-71A6639245E9}"/>
+              </a:ext>
+            </a:extLst>
+          </p:cNvPr>
+          <p:cNvPicPr>
+            <a:picLocks noChangeAspect="1"/>
+          </p:cNvPicPr>
+          <p:nvPr/>
+        </p:nvPicPr>
+        <p:blipFill>
+          <a:blip r:embed="rId9">
+            <a:duotone>
+              <a:schemeClr val="bg2">
+                <a:shade val="45000"/>
+                <a:satMod val="135000"/>
+              </a:schemeClr>
+              <a:prstClr val="white"/>
+            </a:duotone>
+            <a:extLst>
+              <a:ext uri="{BEBA8EAE-BF5A-486C-A8C5-ECC9F3942E4B}">
+                <a14:imgProps xmlns:a14="http://schemas.microsoft.com/office/drawing/2010/main">
+                  <a14:imgLayer r:embed="rId10">
+                    <a14:imgEffect>
+                      <a14:sharpenSoften amount="100000"/>
+                    </a14:imgEffect>
+                    <a14:imgEffect>
+                      <a14:brightnessContrast bright="-100000" contrast="100000"/>
+                    </a14:imgEffect>
+                  </a14:imgLayer>
+                </a14:imgProps>
+              </a:ext>
+              <a:ext uri="{28A0092B-C50C-407E-A947-70E740481C1C}">
+                <a14:useLocalDpi xmlns:a14="http://schemas.microsoft.com/office/drawing/2010/main" val="0"/>
+              </a:ext>
+            </a:extLst>
+          </a:blip>
+          <a:stretch>
+            <a:fillRect/>
+          </a:stretch>
+        </p:blipFill>
+        <p:spPr>
+          <a:xfrm>
+            <a:off x="0" y="-22315"/>
+            <a:ext cx="3481918" cy="1379802"/>
+          </a:xfrm>
+          <a:prstGeom prst="rect">
+            <a:avLst/>
+          </a:prstGeom>
+        </p:spPr>
+      </p:pic>
+      <p:pic>
+        <p:nvPicPr>
+          <p:cNvPr id="17" name="Picture 16">
+            <a:extLst>
+              <a:ext uri="{FF2B5EF4-FFF2-40B4-BE49-F238E27FC236}">
+                <a16:creationId xmlns:a16="http://schemas.microsoft.com/office/drawing/2014/main" id="{C5F134A9-079E-7495-289B-B1CA5924CB70}"/>
+              </a:ext>
+            </a:extLst>
+          </p:cNvPr>
+          <p:cNvPicPr>
+            <a:picLocks noChangeAspect="1"/>
+          </p:cNvPicPr>
+          <p:nvPr/>
+        </p:nvPicPr>
+        <p:blipFill>
+          <a:blip r:embed="rId11">
+            <a:duotone>
+              <a:schemeClr val="bg2">
+                <a:shade val="45000"/>
+                <a:satMod val="135000"/>
+              </a:schemeClr>
+              <a:prstClr val="white"/>
+            </a:duotone>
+            <a:extLst>
+              <a:ext uri="{BEBA8EAE-BF5A-486C-A8C5-ECC9F3942E4B}">
+                <a14:imgProps xmlns:a14="http://schemas.microsoft.com/office/drawing/2010/main">
+                  <a14:imgLayer r:embed="rId12">
+                    <a14:imgEffect>
+                      <a14:sharpenSoften amount="100000"/>
+                    </a14:imgEffect>
+                    <a14:imgEffect>
+                      <a14:brightnessContrast bright="-100000" contrast="100000"/>
+                    </a14:imgEffect>
+                  </a14:imgLayer>
+                </a14:imgProps>
+              </a:ext>
+              <a:ext uri="{28A0092B-C50C-407E-A947-70E740481C1C}">
+                <a14:useLocalDpi xmlns:a14="http://schemas.microsoft.com/office/drawing/2010/main" val="0"/>
+              </a:ext>
+            </a:extLst>
+          </a:blip>
+          <a:stretch>
+            <a:fillRect/>
+          </a:stretch>
+        </p:blipFill>
+        <p:spPr>
+          <a:xfrm>
+            <a:off x="6972299" y="-493486"/>
+            <a:ext cx="4869895" cy="1379803"/>
+          </a:xfrm>
+          <a:prstGeom prst="rect">
+            <a:avLst/>
+          </a:prstGeom>
+        </p:spPr>
+      </p:pic>
+      <p:pic>
+        <p:nvPicPr>
+          <p:cNvPr id="19" name="Picture 18">
+            <a:extLst>
+              <a:ext uri="{FF2B5EF4-FFF2-40B4-BE49-F238E27FC236}">
+                <a16:creationId xmlns:a16="http://schemas.microsoft.com/office/drawing/2014/main" id="{BFC17AFF-C685-A58D-CC0D-78AD4A89D690}"/>
+              </a:ext>
+            </a:extLst>
+          </p:cNvPr>
+          <p:cNvPicPr>
+            <a:picLocks noChangeAspect="1"/>
+          </p:cNvPicPr>
+          <p:nvPr/>
+        </p:nvPicPr>
+        <p:blipFill>
+          <a:blip r:embed="rId13">
+            <a:duotone>
+              <a:schemeClr val="bg2">
+                <a:shade val="45000"/>
+                <a:satMod val="135000"/>
+              </a:schemeClr>
+              <a:prstClr val="white"/>
+            </a:duotone>
+            <a:extLst>
+              <a:ext uri="{BEBA8EAE-BF5A-486C-A8C5-ECC9F3942E4B}">
+                <a14:imgProps xmlns:a14="http://schemas.microsoft.com/office/drawing/2010/main">
+                  <a14:imgLayer r:embed="rId14">
+                    <a14:imgEffect>
+                      <a14:sharpenSoften amount="100000"/>
+                    </a14:imgEffect>
+                    <a14:imgEffect>
+                      <a14:brightnessContrast bright="-100000" contrast="100000"/>
+                    </a14:imgEffect>
+                  </a14:imgLayer>
+                </a14:imgProps>
+              </a:ext>
+              <a:ext uri="{28A0092B-C50C-407E-A947-70E740481C1C}">
+                <a14:useLocalDpi xmlns:a14="http://schemas.microsoft.com/office/drawing/2010/main" val="0"/>
+              </a:ext>
+            </a:extLst>
+          </a:blip>
+          <a:stretch>
+            <a:fillRect/>
+          </a:stretch>
+        </p:blipFill>
+        <p:spPr>
+          <a:xfrm>
+            <a:off x="9439085" y="1101661"/>
+            <a:ext cx="2638425" cy="837391"/>
+          </a:xfrm>
+          <a:prstGeom prst="rect">
+            <a:avLst/>
+          </a:prstGeom>
+        </p:spPr>
+      </p:pic>
+      <p:pic>
+        <p:nvPicPr>
+          <p:cNvPr id="1026" name="Picture 2">
+            <a:extLst>
+              <a:ext uri="{FF2B5EF4-FFF2-40B4-BE49-F238E27FC236}">
+                <a16:creationId xmlns:a16="http://schemas.microsoft.com/office/drawing/2014/main" id="{9B41F92C-BA12-1895-6D10-EBEE9BDE17F1}"/>
+              </a:ext>
+            </a:extLst>
+          </p:cNvPr>
+          <p:cNvPicPr>
+            <a:picLocks noChangeAspect="1" noChangeArrowheads="1"/>
+          </p:cNvPicPr>
+          <p:nvPr/>
+        </p:nvPicPr>
+        <p:blipFill>
+          <a:blip r:embed="rId15">
+            <a:duotone>
+              <a:schemeClr val="bg2">
+                <a:shade val="45000"/>
+                <a:satMod val="135000"/>
+              </a:schemeClr>
+              <a:prstClr val="white"/>
+            </a:duotone>
+            <a:extLst>
+              <a:ext uri="{BEBA8EAE-BF5A-486C-A8C5-ECC9F3942E4B}">
+                <a14:imgProps xmlns:a14="http://schemas.microsoft.com/office/drawing/2010/main">
+                  <a14:imgLayer r:embed="rId16">
+                    <a14:imgEffect>
+                      <a14:sharpenSoften amount="100000"/>
+                    </a14:imgEffect>
+                    <a14:imgEffect>
+                      <a14:brightnessContrast bright="-100000" contrast="100000"/>
+                    </a14:imgEffect>
+                  </a14:imgLayer>
+                </a14:imgProps>
+              </a:ext>
+              <a:ext uri="{28A0092B-C50C-407E-A947-70E740481C1C}">
+                <a14:useLocalDpi xmlns:a14="http://schemas.microsoft.com/office/drawing/2010/main" val="0"/>
+              </a:ext>
+            </a:extLst>
+          </a:blip>
+          <a:srcRect/>
+          <a:stretch>
+            <a:fillRect/>
+          </a:stretch>
+        </p:blipFill>
+        <p:spPr bwMode="auto">
+          <a:xfrm>
+            <a:off x="1596571" y="1027238"/>
+            <a:ext cx="6896031" cy="1713234"/>
+          </a:xfrm>
+          <a:prstGeom prst="rect">
+            <a:avLst/>
+          </a:prstGeom>
+          <a:noFill/>
+          <a:extLst>
+            <a:ext uri="{909E8E84-426E-40DD-AFC4-6F175D3DCCD1}">
+              <a14:hiddenFill xmlns:a14="http://schemas.microsoft.com/office/drawing/2010/main">
+                <a:solidFill>
+                  <a:srgbClr val="FFFFFF"/>
+                </a:solidFill>
+              </a14:hiddenFill>
+            </a:ext>
+          </a:extLst>
+        </p:spPr>
+      </p:pic>
+    </p:spTree>
+    <p:extLst>
+      <p:ext uri="{BB962C8B-B14F-4D97-AF65-F5344CB8AC3E}">
+        <p14:creationId xmlns:p14="http://schemas.microsoft.com/office/powerpoint/2010/main" val="2940813883"/>
+      </p:ext>
+    </p:extLst>
+  </p:cSld>
+  <p:clrMapOvr>
+    <a:masterClrMapping/>
+  </p:clrMapOvr>
+</p:sld>
+</file>
+
 <file path=ppt/theme/theme1.xml><?xml version="1.0" encoding="utf-8"?>
 <a:theme xmlns:a="http://schemas.openxmlformats.org/drawingml/2006/main" name="Office Theme">
   <a:themeElements>

</xml_diff>